<commit_message>
update: change story flow
</commit_message>
<xml_diff>
--- a/docs/Report.pptx
+++ b/docs/Report.pptx
@@ -507,7 +507,7 @@
           <a:lstStyle/>
           <a:p>
             <a:r>
-              <a:t>Good afternoon. This is our autonomous driving project for the Introduction to ROS course. I will walk through our system architecture, then perception, planning, and control, and finish with our test results.</a:t>
+              <a:t>Good afternoon. This is our autonomous driving project for the Introduction to ROS course. I will walk through our system architecture, then planning, perception, and control, and finish with our test results.</a:t>
             </a:r>
           </a:p>
         </p:txBody>
@@ -577,7 +577,7 @@
           <a:lstStyle/>
           <a:p>
             <a:r>
-              <a:t>Our car drives a fixed, roughly 785-meter urban loop, using waypoints published once at startup. We wrote five ROS 2 packages -- interfaces, perception, planning, control, and bringup -- on top of two packages provided by the course. As Figure 1 shows, perception and planning run independently and in parallel, each consuming the simulator's sensor and pose streams. Control is the only node that combines their outputs, and it's the sole path to the car's command topic -- no other node talks to the simulator directly. On the results side, a full benchmark run completed in 272 seconds with zero collisions, zero stalls, one obstacle detour, and two red-light stops handled correctly. Average speed was 2.7 meters per second, peaking at 7.5 on the two longest straights. Figure 5 shows the planned route on the course map, along with the ten predefined goal poses our planner selects between.</a:t>
+              <a:t>Our car drives a fixed, roughly 785-meter urban loop, using waypoints published once at startup. We wrote five ROS 2 packages on top of two provided by the course, and we can think of the system in three layers, matching Figure 1. Planning decides where the car should go -- both the offline base route and live updates like rerouting around obstacles. Perception senses the world -- obstacles and traffic lights. And Control executes that path and reacts in real time -- steering, speed, and safety braking. Perception and planning both feed directly into control, and control is the only node that talks to the car itself. On the results side, a full benchmark run completed in 272 seconds with zero collisions, zero stalls, one obstacle detour, and two red-light stops handled correctly. Average speed was 2.7 meters per second, peaking at 7.5 on the two longest straights. Figure 5 shows the planned route on the course map, with the ten predefined goal poses our planner selects between.</a:t>
             </a:r>
           </a:p>
         </p:txBody>
@@ -647,7 +647,7 @@
           <a:lstStyle/>
           <a:p>
             <a:r>
-              <a:t>Perception has two nodes. obstacle_guard_node takes the depth camera's point cloud, transforms it into the world frame, and measures distance to obstacles along four corridors: main, tight, and two overtake corridors. It keeps points between 0.35 and 3 meters high, filtering out road-surface noise. It's cross-checked against an OctoMap occupancy layer covering the 8-to-35-centimeter band, which catches low, curb-height obstacles the live scan structurally can't see. traffic_light_node uses HSV color-blob detection on the facing signal, filtered by shape to reject false positives like red signage. It only detects red and green -- amber can't be reliably separated from the amber-painted signal casing -- so the controller simply treats 'no fresh green yet' as 'keep waiting.' Importantly, no node in our pipeline ever uses the semantic camera, which claims the assignment's full bonus. One limitation: point-cloud updates run at only about 0.7 hertz, bounded by the simulator's single-core render loop, which caps how fast we can safely cruise.</a:t>
+              <a:t>Planning is where the car decides where to go -- both offline and online. At startup, it builds a smooth base path that stays on the correct side of the road and sets a safe speed for every turn -- tighter turns get lower speeds. But it doesn't stop there: while driving, planning also reacts to the world at the path level. If control confirms a parked obstacle ahead, planning smoothly reroutes around it and returns to the normal path afterward. And it continuously picks the next checkpoint to aim for, out of ten fixed goal points placed around the loop.</a:t>
             </a:r>
           </a:p>
         </p:txBody>
@@ -717,7 +717,7 @@
           <a:lstStyle/>
           <a:p>
             <a:r>
-              <a:t>Planning is a single node, route_planner_node, with two jobs. First, once at startup, it builds a base path: a right-hand lane offset so the car keeps to its own side of the road, iterative smoothing, and a curvature- and acceleration-limited speed profile -- slower through tight turns, respecting braking and acceleration limits between points. This covers both the geometric path-planning role and the kinematic trajectory-planning role. Second, online, it handles two things. When control confirms a static obstacle, the planner shifts a short stretch of the path sideways, blends smoothly back in, and reverts once clear -- locating that stretch with a binary search over arc length rather than rescanning the whole route. It also continuously selects the nearest still-ahead goal from the task's ten predefined poses, using a heading-locked search to handle the fact that our loop crosses near itself.</a:t>
+              <a:t>Perception's job is simple: sense the world and hand that information to planning and control. An obstacle detector uses the depth camera to build a 3D view of the road ahead, and tracks how far away the nearest obstacle is, in the driving lane as well as to the sides. It ignores ground-level noise and only counts real obstacles, and a backup 3D map check catches low, curb-height obstacles the live camera might miss. A traffic-light detector uses color to tell red from green, and deliberately never uses the labeled semantic camera, which earns us the assignment's full bonus. One trade-off: detection only updates about once a second, which limits how fast the car can safely drive.</a:t>
             </a:r>
           </a:p>
         </p:txBody>
@@ -787,7 +787,7 @@
           <a:lstStyle/>
           <a:p>
             <a:r>
-              <a:t>Control lives in pure_pursuit_node. Steering uses a standard pure-pursuit law with a speed-dependent look-ahead distance; throttle combines proportional correction with a feed-forward table, since proportional control alone settles well below the commanded speed. The node exposes the required control-enable service, and it's enabled by default at launch. For safety, an ACC-style gap controller enforces a comfort-stop curve with a 13-meter standoff in the tight corridor, plus a wide-corridor speed ramp between 14 and 38 meters -- this same following logic absorbs the assignment's Event I, a vehicle merging in ahead. A traffic-light state machine stops and releases correctly at each signal. A detour state machine verifies a path is actually clear before committing to it. And independent of all that, every control tick checks whether emergency braking is needed -- decelerating at over 4 meters per second squared -- which is what handles Event II, a vehicle that crosses and brakes hard ahead of us.</a:t>
+              <a:t>Control takes the path from planning and the live readings from perception, and drives the car -- steering and speed. Steering aims at a point on the path ahead, a classic and reliable method. Speed follows adaptive-cruise-control logic, keeping a safe distance from whatever perception detects ahead. On top of that, it stops correctly at red lights, and when perception flags a parked obstacle, control verifies the path is clear before taking a smooth detour around it. Independent of everything else, an emergency-brake check runs continuously and stops the car immediately if a collision risk is detected. And a simple switch means the car is ready to drive automatically as soon as it starts up.</a:t>
             </a:r>
           </a:p>
         </p:txBody>
@@ -4157,7 +4157,22 @@
               </a:defRPr>
             </a:pPr>
             <a:r>
-              <a:t>•  5 custom ROS 2 packages (interfaces, perception, planning, control, bringup)</a:t>
+              <a:t>•  5 custom + 2 course-provided ROS 2 packages</a:t>
+            </a:r>
+          </a:p>
+          <a:p>
+            <a:pPr>
+              <a:spcAft>
+                <a:spcPts val="800"/>
+              </a:spcAft>
+              <a:defRPr sz="1600">
+                <a:solidFill>
+                  <a:srgbClr val="222222"/>
+                </a:solidFill>
+              </a:defRPr>
+            </a:pPr>
+            <a:r>
+              <a:t>•  Three layers, matching Figure 1:</a:t>
             </a:r>
           </a:p>
           <a:p>
@@ -4172,37 +4187,37 @@
               </a:defRPr>
             </a:pPr>
             <a:r>
-              <a:t>‒  plus 2 course-provided packages (simulation bridge, reference controller)</a:t>
+              <a:t>‒  Planning — decides destinations</a:t>
             </a:r>
           </a:p>
           <a:p>
             <a:pPr>
               <a:spcAft>
-                <a:spcPts val="800"/>
+                <a:spcPts val="400"/>
               </a:spcAft>
-              <a:defRPr sz="1600">
-                <a:solidFill>
-                  <a:srgbClr val="222222"/>
+              <a:defRPr sz="1400">
+                <a:solidFill>
+                  <a:srgbClr val="555555"/>
                 </a:solidFill>
               </a:defRPr>
             </a:pPr>
             <a:r>
-              <a:t>•  Perception &amp; planning run independently, in parallel</a:t>
+              <a:t>‒  Perception — senses its surrounding environment</a:t>
             </a:r>
           </a:p>
           <a:p>
             <a:pPr>
               <a:spcAft>
-                <a:spcPts val="800"/>
+                <a:spcPts val="400"/>
               </a:spcAft>
-              <a:defRPr sz="1600">
-                <a:solidFill>
-                  <a:srgbClr val="222222"/>
+              <a:defRPr sz="1400">
+                <a:solidFill>
+                  <a:srgbClr val="555555"/>
                 </a:solidFill>
               </a:defRPr>
             </a:pPr>
             <a:r>
-              <a:t>•  Control is the only node combining their outputs — sole path to /car_command</a:t>
+              <a:t>‒  Control — drives the car &amp; reacts in real time</a:t>
             </a:r>
           </a:p>
           <a:p>
@@ -4296,65 +4311,6 @@
           </a:p>
         </p:txBody>
       </p:sp>
-      <p:pic>
-        <p:nvPicPr>
-          <p:cNvPr id="7" name="Picture 6" descr="route_on_map.png"/>
-          <p:cNvPicPr>
-            <a:picLocks noChangeAspect="1"/>
-          </p:cNvPicPr>
-          <p:nvPr/>
-        </p:nvPicPr>
-        <p:blipFill>
-          <a:blip r:embed="rId3"/>
-          <a:stretch>
-            <a:fillRect/>
-          </a:stretch>
-        </p:blipFill>
-        <p:spPr>
-          <a:xfrm>
-            <a:off x="7620487" y="4434840"/>
-            <a:ext cx="3229905" cy="1920240"/>
-          </a:xfrm>
-          <a:prstGeom prst="rect">
-            <a:avLst/>
-          </a:prstGeom>
-        </p:spPr>
-      </p:pic>
-      <p:sp>
-        <p:nvSpPr>
-          <p:cNvPr id="8" name="TextBox 7"/>
-          <p:cNvSpPr txBox="1"/>
-          <p:nvPr/>
-        </p:nvSpPr>
-        <p:spPr>
-          <a:xfrm>
-            <a:off x="6720840" y="6400800"/>
-            <a:ext cx="5029200" cy="274320"/>
-          </a:xfrm>
-          <a:prstGeom prst="rect">
-            <a:avLst/>
-          </a:prstGeom>
-          <a:noFill/>
-        </p:spPr>
-        <p:txBody>
-          <a:bodyPr wrap="square">
-            <a:spAutoFit/>
-          </a:bodyPr>
-          <a:lstStyle/>
-          <a:p>
-            <a:pPr algn="ctr">
-              <a:defRPr sz="1200" i="1">
-                <a:solidFill>
-                  <a:srgbClr val="555555"/>
-                </a:solidFill>
-              </a:defRPr>
-            </a:pPr>
-            <a:r>
-              <a:t>Fig. 5 — Route with 10 predefined goal poses</a:t>
-            </a:r>
-          </a:p>
-        </p:txBody>
-      </p:sp>
     </p:spTree>
   </p:cSld>
   <p:clrMapOvr>
@@ -4403,7 +4359,7 @@
               </a:defRPr>
             </a:pPr>
             <a:r>
-              <a:t>Perception</a:t>
+              <a:t>Planning — Deciding Destinations</a:t>
             </a:r>
           </a:p>
         </p:txBody>
@@ -4478,14 +4434,29 @@
               <a:spcAft>
                 <a:spcPts val="800"/>
               </a:spcAft>
-              <a:defRPr sz="1900">
+              <a:defRPr sz="2100">
                 <a:solidFill>
                   <a:srgbClr val="222222"/>
                 </a:solidFill>
               </a:defRPr>
             </a:pPr>
             <a:r>
-              <a:t>•  obstacle_guard_node: depth point cloud → world frame</a:t>
+              <a:t>•  Builds the path the car follows — offline, and online corrections while driving</a:t>
+            </a:r>
+          </a:p>
+          <a:p>
+            <a:pPr>
+              <a:spcAft>
+                <a:spcPts val="800"/>
+              </a:spcAft>
+              <a:defRPr sz="2100">
+                <a:solidFill>
+                  <a:srgbClr val="222222"/>
+                </a:solidFill>
+              </a:defRPr>
+            </a:pPr>
+            <a:r>
+              <a:t>•  Offline at startup: smooth base path on the correct side of the road</a:t>
             </a:r>
           </a:p>
           <a:p>
@@ -4493,14 +4464,29 @@
               <a:spcAft>
                 <a:spcPts val="400"/>
               </a:spcAft>
-              <a:defRPr sz="1600">
+              <a:defRPr sz="1700">
                 <a:solidFill>
                   <a:srgbClr val="555555"/>
                 </a:solidFill>
               </a:defRPr>
             </a:pPr>
             <a:r>
-              <a:t>‒  publishes 4 corridor distances: main, tight, overtake-left, overtake-right</a:t>
+              <a:t>‒  sets a safe speed for every turn — tighter turns, lower speed</a:t>
+            </a:r>
+          </a:p>
+          <a:p>
+            <a:pPr>
+              <a:spcAft>
+                <a:spcPts val="800"/>
+              </a:spcAft>
+              <a:defRPr sz="2100">
+                <a:solidFill>
+                  <a:srgbClr val="222222"/>
+                </a:solidFill>
+              </a:defRPr>
+            </a:pPr>
+            <a:r>
+              <a:t>•  Online corrections: reactions to the world at the path level:</a:t>
             </a:r>
           </a:p>
           <a:p>
@@ -4508,14 +4494,14 @@
               <a:spcAft>
                 <a:spcPts val="400"/>
               </a:spcAft>
-              <a:defRPr sz="1600">
+              <a:defRPr sz="1700">
                 <a:solidFill>
                   <a:srgbClr val="555555"/>
                 </a:solidFill>
               </a:defRPr>
             </a:pPr>
             <a:r>
-              <a:t>‒  keeps points 0.35–3.0 m high, filtering road-surface noise</a:t>
+              <a:t>‒  spots a parked obstacle → smoothly reroutes around it, then returns</a:t>
             </a:r>
           </a:p>
           <a:p>
@@ -4523,29 +4509,14 @@
               <a:spcAft>
                 <a:spcPts val="400"/>
               </a:spcAft>
-              <a:defRPr sz="1600">
+              <a:defRPr sz="1700">
                 <a:solidFill>
                   <a:srgbClr val="555555"/>
                 </a:solidFill>
               </a:defRPr>
             </a:pPr>
             <a:r>
-              <a:t>‒  OctoMap cross-check (0.08–0.35 m band) catches curb-height misses</a:t>
-            </a:r>
-          </a:p>
-          <a:p>
-            <a:pPr>
-              <a:spcAft>
-                <a:spcPts val="800"/>
-              </a:spcAft>
-              <a:defRPr sz="1900">
-                <a:solidFill>
-                  <a:srgbClr val="222222"/>
-                </a:solidFill>
-              </a:defRPr>
-            </a:pPr>
-            <a:r>
-              <a:t>•  traffic_light_node: HSV blob detection, shape-filtered</a:t>
+              <a:t>‒  continuously picks the next checkpoint to aim for</a:t>
             </a:r>
           </a:p>
           <a:p>
@@ -4553,59 +4524,73 @@
               <a:spcAft>
                 <a:spcPts val="400"/>
               </a:spcAft>
-              <a:defRPr sz="1600">
+              <a:defRPr sz="1700">
                 <a:solidFill>
                   <a:srgbClr val="555555"/>
                 </a:solidFill>
               </a:defRPr>
             </a:pPr>
             <a:r>
-              <a:t>‒  detects red &amp; green only; amber can't be separated from casing</a:t>
-            </a:r>
-          </a:p>
-          <a:p>
-            <a:pPr>
-              <a:spcAft>
-                <a:spcPts val="400"/>
-              </a:spcAft>
-              <a:defRPr sz="1600">
+              <a:t>‒  out of 10 fixed goal points placed around the loop</a:t>
+            </a:r>
+          </a:p>
+        </p:txBody>
+      </p:sp>
+      <p:pic>
+        <p:nvPicPr>
+          <p:cNvPr id="5" name="Picture 4" descr="route_on_map.png"/>
+          <p:cNvPicPr>
+            <a:picLocks noChangeAspect="1"/>
+          </p:cNvPicPr>
+          <p:nvPr/>
+        </p:nvPicPr>
+        <p:blipFill>
+          <a:blip r:embed="rId2"/>
+          <a:stretch>
+            <a:fillRect/>
+          </a:stretch>
+        </p:blipFill>
+        <p:spPr>
+          <a:xfrm>
+            <a:off x="7620487" y="4434840"/>
+            <a:ext cx="3229905" cy="1920240"/>
+          </a:xfrm>
+          <a:prstGeom prst="rect">
+            <a:avLst/>
+          </a:prstGeom>
+        </p:spPr>
+      </p:pic>
+      <p:sp>
+        <p:nvSpPr>
+          <p:cNvPr id="6" name="TextBox 5"/>
+          <p:cNvSpPr txBox="1"/>
+          <p:nvPr/>
+        </p:nvSpPr>
+        <p:spPr>
+          <a:xfrm>
+            <a:off x="6720840" y="6400800"/>
+            <a:ext cx="5029200" cy="274320"/>
+          </a:xfrm>
+          <a:prstGeom prst="rect">
+            <a:avLst/>
+          </a:prstGeom>
+          <a:noFill/>
+        </p:spPr>
+        <p:txBody>
+          <a:bodyPr wrap="square">
+            <a:spAutoFit/>
+          </a:bodyPr>
+          <a:lstStyle/>
+          <a:p>
+            <a:pPr algn="ctr">
+              <a:defRPr sz="1200" i="1">
                 <a:solidFill>
                   <a:srgbClr val="555555"/>
                 </a:solidFill>
               </a:defRPr>
             </a:pPr>
             <a:r>
-              <a:t>‒  "no fresh green" is treated as "keep waiting"</a:t>
-            </a:r>
-          </a:p>
-          <a:p>
-            <a:pPr>
-              <a:spcAft>
-                <a:spcPts val="800"/>
-              </a:spcAft>
-              <a:defRPr sz="1900">
-                <a:solidFill>
-                  <a:srgbClr val="222222"/>
-                </a:solidFill>
-              </a:defRPr>
-            </a:pPr>
-            <a:r>
-              <a:t>•  No node ever uses the semantic camera — full bonus criterion claimed</a:t>
-            </a:r>
-          </a:p>
-          <a:p>
-            <a:pPr>
-              <a:spcAft>
-                <a:spcPts val="800"/>
-              </a:spcAft>
-              <a:defRPr sz="1900">
-                <a:solidFill>
-                  <a:srgbClr val="222222"/>
-                </a:solidFill>
-              </a:defRPr>
-            </a:pPr>
-            <a:r>
-              <a:t>•  Limitation: ~0.7 Hz update rate, capped by simulator's single-core loop</a:t>
+              <a:t>Fig. 5 — Route with 10 predefined goal poses</a:t>
             </a:r>
           </a:p>
         </p:txBody>
@@ -4658,7 +4643,7 @@
               </a:defRPr>
             </a:pPr>
             <a:r>
-              <a:t>Planning</a:t>
+              <a:t>Perception — Sensing the World</a:t>
             </a:r>
           </a:p>
         </p:txBody>
@@ -4740,7 +4725,7 @@
               </a:defRPr>
             </a:pPr>
             <a:r>
-              <a:t>•  route_planner_node — two responsibilities</a:t>
+              <a:t>•  Feeds real-time awareness to both planning and control</a:t>
             </a:r>
           </a:p>
           <a:p>
@@ -4755,7 +4740,7 @@
               </a:defRPr>
             </a:pPr>
             <a:r>
-              <a:t>•  1. Base path (once, at startup):</a:t>
+              <a:t>•  Obstacle detection: depth camera builds a 3D view of the road ahead</a:t>
             </a:r>
           </a:p>
           <a:p>
@@ -4770,7 +4755,7 @@
               </a:defRPr>
             </a:pPr>
             <a:r>
-              <a:t>‒  right-hand lane offset, so the car keeps its own side of the road</a:t>
+              <a:t>‒  tracks distance to the nearest obstacle, in the driving lane and to the sides</a:t>
             </a:r>
           </a:p>
           <a:p>
@@ -4785,7 +4770,7 @@
               </a:defRPr>
             </a:pPr>
             <a:r>
-              <a:t>‒  iterative smoothing + curvature/acceleration-limited speed profile</a:t>
+              <a:t>‒  ignores ground-level noise, only counts real obstacles</a:t>
             </a:r>
           </a:p>
           <a:p>
@@ -4800,7 +4785,7 @@
               </a:defRPr>
             </a:pPr>
             <a:r>
-              <a:t>‒  covers both the path-planner and trajectory-planner roles</a:t>
+              <a:t>‒  backup 3D map check catches low, curb-height obstacles the camera misses</a:t>
             </a:r>
           </a:p>
           <a:p>
@@ -4815,67 +4800,37 @@
               </a:defRPr>
             </a:pPr>
             <a:r>
-              <a:t>•  2. Online updates:</a:t>
+              <a:t>•  Traffic-light detection: RGB camera tells red from green</a:t>
             </a:r>
           </a:p>
           <a:p>
             <a:pPr>
               <a:spcAft>
-                <a:spcPts val="400"/>
+                <a:spcPts val="800"/>
               </a:spcAft>
-              <a:defRPr sz="1600">
-                <a:solidFill>
-                  <a:srgbClr val="555555"/>
+              <a:defRPr sz="1900">
+                <a:solidFill>
+                  <a:srgbClr val="222222"/>
                 </a:solidFill>
               </a:defRPr>
             </a:pPr>
             <a:r>
-              <a:t>‒  detour replanning around confirmed static obstacles</a:t>
+              <a:t>•  Deliberately never uses the labeled (semantic) camera — full bonus earned</a:t>
             </a:r>
           </a:p>
           <a:p>
             <a:pPr>
               <a:spcAft>
-                <a:spcPts val="400"/>
+                <a:spcPts val="800"/>
               </a:spcAft>
-              <a:defRPr sz="1600">
-                <a:solidFill>
-                  <a:srgbClr val="555555"/>
+              <a:defRPr sz="1900">
+                <a:solidFill>
+                  <a:srgbClr val="222222"/>
                 </a:solidFill>
               </a:defRPr>
             </a:pPr>
             <a:r>
-              <a:t>‒  located via binary search on arc length, not full rescans</a:t>
-            </a:r>
-          </a:p>
-          <a:p>
-            <a:pPr>
-              <a:spcAft>
-                <a:spcPts val="400"/>
-              </a:spcAft>
-              <a:defRPr sz="1600">
-                <a:solidFill>
-                  <a:srgbClr val="555555"/>
-                </a:solidFill>
-              </a:defRPr>
-            </a:pPr>
-            <a:r>
-              <a:t>‒  smooth blend in/out; reverts once obstacle is clear</a:t>
-            </a:r>
-          </a:p>
-          <a:p>
-            <a:pPr>
-              <a:spcAft>
-                <a:spcPts val="400"/>
-              </a:spcAft>
-              <a:defRPr sz="1600">
-                <a:solidFill>
-                  <a:srgbClr val="555555"/>
-                </a:solidFill>
-              </a:defRPr>
-            </a:pPr>
-            <a:r>
-              <a:t>‒  continuous nearest-still-ahead goal selection over 10 fixed poses</a:t>
+              <a:t>•  Trade-off: detection updates only ~once a second, limiting safe driving speed</a:t>
             </a:r>
           </a:p>
         </p:txBody>
@@ -4928,7 +4883,7 @@
               </a:defRPr>
             </a:pPr>
             <a:r>
-              <a:t>Control</a:t>
+              <a:t>Control — Driving &amp; Reacting in Real Time</a:t>
             </a:r>
           </a:p>
         </p:txBody>
@@ -5010,7 +4965,7 @@
               </a:defRPr>
             </a:pPr>
             <a:r>
-              <a:t>•  pure_pursuit_node: pure-pursuit steering + proportional/feed-forward throttle</a:t>
+              <a:t>•  Takes the path from planning and the readings from perception, drives the car</a:t>
             </a:r>
           </a:p>
           <a:p>
@@ -5025,7 +4980,7 @@
               </a:defRPr>
             </a:pPr>
             <a:r>
-              <a:t>•  /control/enable service — required, enabled by default at launch</a:t>
+              <a:t>•  Steering aims at a point ahead on the path (classic "pursuit" steering)</a:t>
             </a:r>
           </a:p>
           <a:p>
@@ -5040,37 +4995,7 @@
               </a:defRPr>
             </a:pPr>
             <a:r>
-              <a:t>•  ACC-style gap control:</a:t>
-            </a:r>
-          </a:p>
-          <a:p>
-            <a:pPr>
-              <a:spcAft>
-                <a:spcPts val="400"/>
-              </a:spcAft>
-              <a:defRPr sz="1600">
-                <a:solidFill>
-                  <a:srgbClr val="555555"/>
-                </a:solidFill>
-              </a:defRPr>
-            </a:pPr>
-            <a:r>
-              <a:t>‒  13 m standoff comfort-stop curve in the tight corridor</a:t>
-            </a:r>
-          </a:p>
-          <a:p>
-            <a:pPr>
-              <a:spcAft>
-                <a:spcPts val="400"/>
-              </a:spcAft>
-              <a:defRPr sz="1600">
-                <a:solidFill>
-                  <a:srgbClr val="555555"/>
-                </a:solidFill>
-              </a:defRPr>
-            </a:pPr>
-            <a:r>
-              <a:t>‒  14–38 m wide-corridor speed ramp; also absorbs Event I (NPC merge)</a:t>
+              <a:t>•  Speed follows a safe distance from anything ahead — like adaptive cruise control</a:t>
             </a:r>
           </a:p>
           <a:p>
@@ -5085,7 +5010,7 @@
               </a:defRPr>
             </a:pPr>
             <a:r>
-              <a:t>•  Traffic-light stop/go state machine</a:t>
+              <a:t>•  Stops correctly at red lights, resumes on green</a:t>
             </a:r>
           </a:p>
           <a:p>
@@ -5100,7 +5025,7 @@
               </a:defRPr>
             </a:pPr>
             <a:r>
-              <a:t>•  Obstacle detour state machine (verify-before-commit)</a:t>
+              <a:t>•  When perception flags a parked obstacle → verifies it's clear, takes a smooth detour</a:t>
             </a:r>
           </a:p>
           <a:p>
@@ -5115,7 +5040,22 @@
               </a:defRPr>
             </a:pPr>
             <a:r>
-              <a:t>•  Emergency stop: brakes if required deceleration &gt; 4.0 m/s² (Event II)</a:t>
+              <a:t>•  Independent emergency brake if a collision risk is detected</a:t>
+            </a:r>
+          </a:p>
+          <a:p>
+            <a:pPr>
+              <a:spcAft>
+                <a:spcPts val="800"/>
+              </a:spcAft>
+              <a:defRPr sz="1900">
+                <a:solidFill>
+                  <a:srgbClr val="222222"/>
+                </a:solidFill>
+              </a:defRPr>
+            </a:pPr>
+            <a:r>
+              <a:t>•  Car is ready to drive automatically as soon as it starts up</a:t>
             </a:r>
           </a:p>
         </p:txBody>

</xml_diff>

<commit_message>
update: full check of speech
</commit_message>
<xml_diff>
--- a/docs/Report.pptx
+++ b/docs/Report.pptx
@@ -647,7 +647,7 @@
           <a:lstStyle/>
           <a:p>
             <a:r>
-              <a:t>Planning is where the car decides where to go -- both offline and online. At startup, it builds a smooth base path that stays on the correct side of the road and sets a safe speed for every turn -- tighter turns get lower speeds. But it doesn't stop there: while driving, planning also reacts to the world at the path level. If control confirms a parked obstacle ahead, planning smoothly reroutes around it and returns to the normal path afterward. And it continuously picks the next checkpoint to aim for, out of ten fixed goal points placed around the loop.</a:t>
+              <a:t>Planning is where the car decides where to go -- both offline and online. At startup, it builds a smooth base path that stays on the right side of the road and sets a safe speed for every turn, eventually, tighter turns get lower speeds. But it doesn't stop there: while driving, planning also reacts to the world at the path level. When the perception node flags an obstacle ahead and the control node confirms it's actually parked, planning smoothly reroutes around it and returns to the normal path afterward. And it continuously picks the next checkpoint to aim for. </a:t>
             </a:r>
           </a:p>
         </p:txBody>
@@ -787,7 +787,7 @@
           <a:lstStyle/>
           <a:p>
             <a:r>
-              <a:t>Control takes the path from planning and the live readings from perception, and drives the car -- steering and speed. Steering aims at a point on the path ahead, a classic and reliable method. Speed follows adaptive-cruise-control logic, keeping a safe distance from whatever perception detects ahead. On top of that, it stops correctly at red lights, and when perception flags a parked obstacle, control verifies the path is clear before taking a smooth detour around it. Independent of everything else, an emergency-brake check runs continuously and stops the car immediately if a collision risk is detected. And a simple switch means the car is ready to drive automatically as soon as it starts up.</a:t>
+              <a:t>Control takes the path from planning and the live readings from perception, and drives the car -- steering and speed. Steering aims at a point on the path ahead, a classic and reliable method. Speed follows adaptive-cruise-control logic, keeping a safe distance from whatever perception detects ahead. On top of that, it stops correctly at red lights, and when the perception node flags a parked obstacle, the control node verifies the path is clear before taking a smooth detour around it. Independent of everything else, an emergency-brake check runs continuously and stops the car immediately if a collision risk is detected. And a simple switch means the car is ready to drive automatically as soon as it starts up.</a:t>
             </a:r>
           </a:p>
         </p:txBody>
@@ -857,7 +857,7 @@
           <a:lstStyle/>
           <a:p>
             <a:r>
-              <a:t>Figure 3 shows our driven path colored by speed, and Figure 4 shows that same speed against distance travelled. The fastest segments are the two longest clear straights, where we peak at 7.5 meters per second. The near-zero dips mark where we're slower: the detour location, the two traffic lights that were red on this run, and two ACC-managed slowdowns for the assignment's Event one and Event two encounters. One design choice mattered a lot here: we originally capped wide-corridor speed at a flat 2.5 meters per second, but roadside furniture sits in that corridor sixty to ninety percent of route time, so it was starving the whole run. Ramping that cap up to 6.5 meters per second fixed it route-wide, not just locally.</a:t>
+              <a:t>The full benchmark run completed successfully: 272 seconds, zero collisions, zero stalls. Figure 3 shows our driven path colored by speed, and Figure 4 shows that same speed against distance travelled. The fastest segments are the two longest clear straights, where we peak at 7.5 meters per second. The near-zero dips mark where we're slower: the detour location, the two traffic lights that were red on this run, and two Adaptive Cruise Control, or ACC, slowdowns for the assignment's Event one and Event two encounters. One design choice mattered a lot here: we originally capped wide-corridor speed at a flat 2.5 meters per second, but roadside furniture sits in that corridor sixty to ninety percent of route time, so it was starving the whole run. Ramping that cap up to 6.5 meters per second fixed it route-wide, not just locally.</a:t>
             </a:r>
           </a:p>
         </p:txBody>
@@ -4232,7 +4232,7 @@
               </a:defRPr>
             </a:pPr>
             <a:r>
-              <a:t>•  Benchmark run: 272 s, zero collisions, zero stalls, 1 detour, 2 correct light stops</a:t>
+              <a:t>•  Full benchmark run: 272 s, zero collisions, zero stalls, 1 detour, 2 correct red light stops</a:t>
             </a:r>
           </a:p>
           <a:p>
@@ -4306,7 +4306,66 @@
               </a:defRPr>
             </a:pPr>
             <a:r>
-              <a:t>Fig. 1 — Node/data-flow architecture</a:t>
+              <a:t>Node/data-flow architecture</a:t>
+            </a:r>
+          </a:p>
+        </p:txBody>
+      </p:sp>
+      <p:pic>
+        <p:nvPicPr>
+          <p:cNvPr id="7" name="Picture 6" descr="route_on_map.png"/>
+          <p:cNvPicPr>
+            <a:picLocks noChangeAspect="1"/>
+          </p:cNvPicPr>
+          <p:nvPr/>
+        </p:nvPicPr>
+        <p:blipFill>
+          <a:blip r:embed="rId3"/>
+          <a:stretch>
+            <a:fillRect/>
+          </a:stretch>
+        </p:blipFill>
+        <p:spPr>
+          <a:xfrm>
+            <a:off x="7620487" y="4434840"/>
+            <a:ext cx="3229905" cy="1920240"/>
+          </a:xfrm>
+          <a:prstGeom prst="rect">
+            <a:avLst/>
+          </a:prstGeom>
+        </p:spPr>
+      </p:pic>
+      <p:sp>
+        <p:nvSpPr>
+          <p:cNvPr id="8" name="TextBox 7"/>
+          <p:cNvSpPr txBox="1"/>
+          <p:nvPr/>
+        </p:nvSpPr>
+        <p:spPr>
+          <a:xfrm>
+            <a:off x="6720840" y="6400800"/>
+            <a:ext cx="5029200" cy="274320"/>
+          </a:xfrm>
+          <a:prstGeom prst="rect">
+            <a:avLst/>
+          </a:prstGeom>
+          <a:noFill/>
+        </p:spPr>
+        <p:txBody>
+          <a:bodyPr wrap="square">
+            <a:spAutoFit/>
+          </a:bodyPr>
+          <a:lstStyle/>
+          <a:p>
+            <a:pPr algn="ctr">
+              <a:defRPr sz="1300" i="1">
+                <a:solidFill>
+                  <a:srgbClr val="555555"/>
+                </a:solidFill>
+              </a:defRPr>
+            </a:pPr>
+            <a:r>
+              <a:t>Route with 10 predefined goal poses</a:t>
             </a:r>
           </a:p>
         </p:txBody>
@@ -4417,7 +4476,7 @@
         <p:spPr>
           <a:xfrm>
             <a:off x="457200" y="1143000"/>
-            <a:ext cx="6035040" cy="5394960"/>
+            <a:ext cx="11277295" cy="5394960"/>
           </a:xfrm>
           <a:prstGeom prst="rect">
             <a:avLst/>
@@ -4434,7 +4493,7 @@
               <a:spcAft>
                 <a:spcPts val="800"/>
               </a:spcAft>
-              <a:defRPr sz="1900">
+              <a:defRPr sz="2300">
                 <a:solidFill>
                   <a:srgbClr val="222222"/>
                 </a:solidFill>
@@ -4449,7 +4508,7 @@
               <a:spcAft>
                 <a:spcPts val="800"/>
               </a:spcAft>
-              <a:defRPr sz="1900">
+              <a:defRPr sz="2300">
                 <a:solidFill>
                   <a:srgbClr val="222222"/>
                 </a:solidFill>
@@ -4464,7 +4523,7 @@
               <a:spcAft>
                 <a:spcPts val="400"/>
               </a:spcAft>
-              <a:defRPr sz="1600">
+              <a:defRPr sz="1900">
                 <a:solidFill>
                   <a:srgbClr val="555555"/>
                 </a:solidFill>
@@ -4479,7 +4538,7 @@
               <a:spcAft>
                 <a:spcPts val="800"/>
               </a:spcAft>
-              <a:defRPr sz="1900">
+              <a:defRPr sz="2300">
                 <a:solidFill>
                   <a:srgbClr val="222222"/>
                 </a:solidFill>
@@ -4494,14 +4553,14 @@
               <a:spcAft>
                 <a:spcPts val="400"/>
               </a:spcAft>
-              <a:defRPr sz="1600">
+              <a:defRPr sz="1900">
                 <a:solidFill>
                   <a:srgbClr val="555555"/>
                 </a:solidFill>
               </a:defRPr>
             </a:pPr>
             <a:r>
-              <a:t>‒  spots a parked obstacle → smoothly reroutes around it, then returns</a:t>
+              <a:t>‒  when the perception node flags an obstacle and the control node confirms it's parked</a:t>
             </a:r>
           </a:p>
           <a:p>
@@ -4509,14 +4568,14 @@
               <a:spcAft>
                 <a:spcPts val="400"/>
               </a:spcAft>
-              <a:defRPr sz="1600">
+              <a:defRPr sz="1900">
                 <a:solidFill>
                   <a:srgbClr val="555555"/>
                 </a:solidFill>
               </a:defRPr>
             </a:pPr>
             <a:r>
-              <a:t>‒  continuously picks the next checkpoint to aim for</a:t>
+              <a:t>‒  → smoothly reroutes around it, then returns</a:t>
             </a:r>
           </a:p>
           <a:p>
@@ -4524,73 +4583,14 @@
               <a:spcAft>
                 <a:spcPts val="400"/>
               </a:spcAft>
-              <a:defRPr sz="1600">
+              <a:defRPr sz="1900">
                 <a:solidFill>
                   <a:srgbClr val="555555"/>
                 </a:solidFill>
               </a:defRPr>
             </a:pPr>
             <a:r>
-              <a:t>‒  out of 10 fixed goal points placed around the loop</a:t>
-            </a:r>
-          </a:p>
-        </p:txBody>
-      </p:sp>
-      <p:pic>
-        <p:nvPicPr>
-          <p:cNvPr id="5" name="Picture 4" descr="route_on_map.png"/>
-          <p:cNvPicPr>
-            <a:picLocks noChangeAspect="1"/>
-          </p:cNvPicPr>
-          <p:nvPr/>
-        </p:nvPicPr>
-        <p:blipFill>
-          <a:blip r:embed="rId2"/>
-          <a:stretch>
-            <a:fillRect/>
-          </a:stretch>
-        </p:blipFill>
-        <p:spPr>
-          <a:xfrm>
-            <a:off x="6928365" y="2377440"/>
-            <a:ext cx="4614150" cy="2743200"/>
-          </a:xfrm>
-          <a:prstGeom prst="rect">
-            <a:avLst/>
-          </a:prstGeom>
-        </p:spPr>
-      </p:pic>
-      <p:sp>
-        <p:nvSpPr>
-          <p:cNvPr id="6" name="TextBox 5"/>
-          <p:cNvSpPr txBox="1"/>
-          <p:nvPr/>
-        </p:nvSpPr>
-        <p:spPr>
-          <a:xfrm>
-            <a:off x="6720840" y="5166360"/>
-            <a:ext cx="5029200" cy="274320"/>
-          </a:xfrm>
-          <a:prstGeom prst="rect">
-            <a:avLst/>
-          </a:prstGeom>
-          <a:noFill/>
-        </p:spPr>
-        <p:txBody>
-          <a:bodyPr wrap="square">
-            <a:spAutoFit/>
-          </a:bodyPr>
-          <a:lstStyle/>
-          <a:p>
-            <a:pPr algn="ctr">
-              <a:defRPr sz="1300" i="1">
-                <a:solidFill>
-                  <a:srgbClr val="555555"/>
-                </a:solidFill>
-              </a:defRPr>
-            </a:pPr>
-            <a:r>
-              <a:t>Fig. 5 — Route with 10 predefined goal poses</a:t>
+              <a:t>‒  continuously picks the next checkpoint to aim for</a:t>
             </a:r>
           </a:p>
         </p:txBody>
@@ -5016,46 +5016,46 @@
           <a:p>
             <a:pPr>
               <a:spcAft>
-                <a:spcPts val="800"/>
+                <a:spcPts val="400"/>
               </a:spcAft>
-              <a:defRPr sz="2300">
-                <a:solidFill>
-                  <a:srgbClr val="222222"/>
+              <a:defRPr sz="1900">
+                <a:solidFill>
+                  <a:srgbClr val="555555"/>
                 </a:solidFill>
               </a:defRPr>
             </a:pPr>
             <a:r>
-              <a:t>•  When perception flags a parked obstacle → verifies it's clear, takes a smooth detour</a:t>
+              <a:t>‒  When the perception node flags a parked obstacle → verifies it's clear, takes a smooth detour</a:t>
             </a:r>
           </a:p>
           <a:p>
             <a:pPr>
               <a:spcAft>
-                <a:spcPts val="800"/>
+                <a:spcPts val="400"/>
               </a:spcAft>
-              <a:defRPr sz="2300">
-                <a:solidFill>
-                  <a:srgbClr val="222222"/>
+              <a:defRPr sz="1900">
+                <a:solidFill>
+                  <a:srgbClr val="555555"/>
                 </a:solidFill>
               </a:defRPr>
             </a:pPr>
             <a:r>
-              <a:t>•  Independent emergency brake if a collision risk is detected</a:t>
+              <a:t>‒  Independent emergency brake if a collision risk is detected</a:t>
             </a:r>
           </a:p>
           <a:p>
             <a:pPr>
               <a:spcAft>
-                <a:spcPts val="800"/>
+                <a:spcPts val="400"/>
               </a:spcAft>
-              <a:defRPr sz="2300">
-                <a:solidFill>
-                  <a:srgbClr val="222222"/>
+              <a:defRPr sz="1900">
+                <a:solidFill>
+                  <a:srgbClr val="555555"/>
                 </a:solidFill>
               </a:defRPr>
             </a:pPr>
             <a:r>
-              <a:t>•  Car is ready to drive automatically as soon as it starts up</a:t>
+              <a:t>‒  Car is ready to drive automatically as soon as it starts up</a:t>
             </a:r>
           </a:p>
         </p:txBody>
@@ -5190,7 +5190,7 @@
               </a:defRPr>
             </a:pPr>
             <a:r>
-              <a:t>•  Fastest: two longest clear straights, peak 7.5 m/s</a:t>
+              <a:t>•  Full benchmark run completed successfully: 272 s, zero collisions, zero stalls</a:t>
             </a:r>
           </a:p>
           <a:p>
@@ -5205,7 +5205,22 @@
               </a:defRPr>
             </a:pPr>
             <a:r>
-              <a:t>•  Slowest (near-zero dips): detour spot, TrafficLight2/TrafficLight3 stops, 2 ACC car following slowdowns</a:t>
+              <a:t>•  Fastest: two longest clear straights, peak 7.5 m/s</a:t>
+            </a:r>
+          </a:p>
+          <a:p>
+            <a:pPr>
+              <a:spcAft>
+                <a:spcPts val="800"/>
+              </a:spcAft>
+              <a:defRPr sz="1900">
+                <a:solidFill>
+                  <a:srgbClr val="222222"/>
+                </a:solidFill>
+              </a:defRPr>
+            </a:pPr>
+            <a:r>
+              <a:t>•  Slowest (near-zero dips): detour spot, TrafficLight2/TrafficLight3 stops, 2 Adaptive Cruise Control (ACC) slowdowns</a:t>
             </a:r>
           </a:p>
           <a:p>
@@ -5235,7 +5250,7 @@
               </a:defRPr>
             </a:pPr>
             <a:r>
-              <a:t>•  Design choice that mattered: wide-corridor cap 2.5 → 2.5~6.5 m/s ramp</a:t>
+              <a:t>•  Design choice 1.: wide-corridor cap 2.5 → 2.5~6.5 m/s ramp</a:t>
             </a:r>
           </a:p>
           <a:p>
@@ -5280,7 +5295,7 @@
               </a:defRPr>
             </a:pPr>
             <a:r>
-              <a:t>•  Extra compute is localized to the detour segment (replan + re-profile)</a:t>
+              <a:t>•  Design choice 2.: extra compute is localized to the detour segment (replan + re-profile)</a:t>
             </a:r>
           </a:p>
         </p:txBody>
@@ -5339,7 +5354,7 @@
               </a:defRPr>
             </a:pPr>
             <a:r>
-              <a:t>Fig. 3 — Driven path colored by speed</a:t>
+              <a:t>Driven path colored by speed</a:t>
             </a:r>
           </a:p>
         </p:txBody>
@@ -5398,7 +5413,7 @@
               </a:defRPr>
             </a:pPr>
             <a:r>
-              <a:t>Fig. 4 — Speed vs. distance travelled</a:t>
+              <a:t>Speed vs. distance travelled</a:t>
             </a:r>
           </a:p>
         </p:txBody>

</xml_diff>

<commit_message>
update: renew report ppt
</commit_message>
<xml_diff>
--- a/docs/Report.pptx
+++ b/docs/Report.pptx
@@ -577,7 +577,7 @@
           <a:lstStyle/>
           <a:p>
             <a:r>
-              <a:t>Our car drives a fixed, roughly 785-meter urban loop, using waypoints published once at startup. We wrote five ROS 2 packages on top of two provided by the course, and we can think of the system in three layers, matching Figure 1. Planning decides where the car should go -- both the offline base route and live updates like rerouting around obstacles. Perception senses the world -- obstacles and traffic lights. And Control executes that path and reacts in real time -- steering, speed, and safety braking. Perception and planning both feed directly into control, and control is the only node that talks to the car itself. On the results side, a full benchmark run completed in 272 seconds with zero collisions, zero stalls, one obstacle detour, and two red-light stops handled correctly. Average speed was 2.7 meters per second, peaking at 7.5 on the two longest straights. Figure 5 shows the planned route on the course map, with the ten predefined goal poses our planner selects between.</a:t>
+              <a:t>Our car drives a fixed, roughly 785-meter urban loop, using waypoints published once at startup. We wrote five ROS 2 packages on top of two provided by the course, and we can think of the system in three layers, matching Figure 1. Planning decides where the car should go -- both the offline base route and online updates like rerouting around obstacles. Perception senses the world, including obstacles and traffic lights. And Control executes that path and reacts in real time, like steering, speed, and safety braking. Perception and planning both feed directly into control, and control is the only node that talks to the car itself. On the results side, a full benchmark run completed in 272 seconds with zero collisions, zero stalls, one obstacle detour, and two red-light stops handled correctly. Average speed was 2.7 meters per second, peaking at 7.5 on the two longest straights. The figure below shows the planned route on the course map, with the ten predefined goal poses our planner selects between.</a:t>
             </a:r>
           </a:p>
         </p:txBody>
@@ -717,7 +717,7 @@
           <a:lstStyle/>
           <a:p>
             <a:r>
-              <a:t>Perception's job is simple: sense the world and hand that information to planning and control. An obstacle detector uses the depth camera to build a 3D view of the road ahead, and tracks how far away the nearest obstacle is, in the driving lane as well as to the sides. It ignores ground-level noise and only counts real obstacles, and a backup 3D map check catches low, curb-height obstacles the live camera might miss. A traffic-light detector uses color to tell red from green, and deliberately never uses the labeled semantic camera, which earns us the assignment's full bonus. One trade-off: detection only updates about once a second, which limits how fast the car can safely drive.</a:t>
+              <a:t>Perception's job is simple: sense the world and hand that information to planning and control. An obstacle detector uses the depth camera to build a 3D view of the road ahead, and tracks how far away the nearest obstacle is, in the driving lane as well as to the sides. It ignores ground-level noise and only counts real obstacles, and a backup 3D map check catches low, curb-height obstacles the live camera might miss. A traffic-light detector uses color to tell red from green, and deliberately never uses the labeled semantic camera. </a:t>
             </a:r>
           </a:p>
         </p:txBody>
@@ -787,7 +787,7 @@
           <a:lstStyle/>
           <a:p>
             <a:r>
-              <a:t>Control takes the path from planning and the live readings from perception, and drives the car -- steering and speed. Steering aims at a point on the path ahead, a classic and reliable method. Speed follows adaptive-cruise-control logic, keeping a safe distance from whatever perception detects ahead. On top of that, it stops correctly at red lights, and when the perception node flags a parked obstacle, the control node verifies the path is clear before taking a smooth detour around it. Independent of everything else, an emergency-brake check runs continuously and stops the car immediately if a collision risk is detected. And a simple switch means the car is ready to drive automatically as soon as it starts up.</a:t>
+              <a:t>Control takes the path from planning and the live readings from perception, and drives the car -- steering and speed. Steering aims at a point on the path ahead, a classic and reliable method. Speed follows adaptive-cruise-control logic, keeping a safe distance from whatever perception detects ahead. On top of that, it stops correctly at red lights, and when the perception node flags a parked obstacle, the control node verifies the path is clear before taking a smooth detour around it. Independent of everything else, an emergency-brake check runs continuously and stops the car immediately if a collision risk is detected. </a:t>
             </a:r>
           </a:p>
         </p:txBody>
@@ -857,7 +857,7 @@
           <a:lstStyle/>
           <a:p>
             <a:r>
-              <a:t>The full benchmark run completed successfully: 272 seconds, zero collisions, zero stalls. Figure 3 shows our driven path colored by speed, and Figure 4 shows that same speed against distance travelled. The fastest segments are the two longest clear straights, where we peak at 7.5 meters per second. The near-zero dips mark where we're slower: the detour location, the two traffic lights that were red on this run, and two Adaptive Cruise Control, or ACC, slowdowns for the assignment's Event one and Event two encounters. One design choice mattered a lot here: we originally capped wide-corridor speed at a flat 2.5 meters per second, but roadside furniture sits in that corridor sixty to ninety percent of route time, so it was starving the whole run. Ramping that cap up to 6.5 meters per second fixed it route-wide, not just locally.</a:t>
+              <a:t>The full benchmark run completed successfully: 272 seconds with zero collisions and zero stalls. Figure 3 shows our driven path colored by speed, and Figure 4 shows that same speed against the distance that was travelled. The fastest segments are the two longest clear straights, where we peak at 7.5 meters per second. The near-zero dips mark where we're slower: the detour location, the two traffic lights that were red on this run, and two Adaptive Cruise Control, or ACC, slowdowns during vehicle merging and emergency brake. One design choice mattered a lot here: we originally capped wide-corridor speed at a flat 2.5 meters per second, but roadside furniture sits in that corridor sixty to ninety percent of route time, so it was starving the whole run. Ramping that cap up to 6.5 meters per second fixed it route-wide, not just locally.</a:t>
             </a:r>
           </a:p>
         </p:txBody>
@@ -4806,31 +4806,16 @@
           <a:p>
             <a:pPr>
               <a:spcAft>
-                <a:spcPts val="800"/>
+                <a:spcPts val="400"/>
               </a:spcAft>
-              <a:defRPr sz="2300">
-                <a:solidFill>
-                  <a:srgbClr val="222222"/>
+              <a:defRPr sz="1900">
+                <a:solidFill>
+                  <a:srgbClr val="555555"/>
                 </a:solidFill>
               </a:defRPr>
             </a:pPr>
             <a:r>
-              <a:t>•  Deliberately never uses the labeled (semantic) camera — full bonus earned</a:t>
-            </a:r>
-          </a:p>
-          <a:p>
-            <a:pPr>
-              <a:spcAft>
-                <a:spcPts val="800"/>
-              </a:spcAft>
-              <a:defRPr sz="2300">
-                <a:solidFill>
-                  <a:srgbClr val="222222"/>
-                </a:solidFill>
-              </a:defRPr>
-            </a:pPr>
-            <a:r>
-              <a:t>•  Trade-off: detection updates only ~once a second, limiting safe driving speed</a:t>
+              <a:t>‒  Deliberately never uses the labeled (semantic) camera</a:t>
             </a:r>
           </a:p>
         </p:txBody>
@@ -5041,21 +5026,6 @@
             </a:pPr>
             <a:r>
               <a:t>‒  Independent emergency brake if a collision risk is detected</a:t>
-            </a:r>
-          </a:p>
-          <a:p>
-            <a:pPr>
-              <a:spcAft>
-                <a:spcPts val="400"/>
-              </a:spcAft>
-              <a:defRPr sz="1900">
-                <a:solidFill>
-                  <a:srgbClr val="555555"/>
-                </a:solidFill>
-              </a:defRPr>
-            </a:pPr>
-            <a:r>
-              <a:t>‒  Car is ready to drive automatically as soon as it starts up</a:t>
             </a:r>
           </a:p>
         </p:txBody>

</xml_diff>